<commit_message>
update slides and pdf
</commit_message>
<xml_diff>
--- a/slides/Lecture_06_SensitivitySampling.pptx
+++ b/slides/Lecture_06_SensitivitySampling.pptx
@@ -305,7 +305,7 @@
             <a:fld id="{05CC55C5-3AE8-4299-988D-DFB8217A9B4E}" type="datetimeFigureOut">
               <a:rPr lang="en-GB" smtClean="0"/>
               <a:pPr/>
-              <a:t>18/04/2023</a:t>
+              <a:t>03/09/2026</a:t>
             </a:fld>
             <a:endParaRPr lang="en-GB" dirty="0"/>
           </a:p>
@@ -450,7 +450,7 @@
             <a:lvl1pPr marL="0" indent="0">
               <a:buNone/>
               <a:defRPr sz="1800" b="0" i="0" baseline="0">
-                <a:latin typeface="open sans" charset="0"/>
+                <a:latin typeface="Open Sans" charset="0"/>
               </a:defRPr>
             </a:lvl1pPr>
           </a:lstStyle>
@@ -461,7 +461,7 @@
                 <a:solidFill>
                   <a:schemeClr val="tx1"/>
                 </a:solidFill>
-                <a:latin typeface="open sans" charset="0"/>
+                <a:latin typeface="Open Sans" charset="0"/>
               </a:rPr>
               <a:t>Body Header</a:t>
             </a:r>
@@ -472,7 +472,7 @@
                 <a:solidFill>
                   <a:schemeClr val="tx1"/>
                 </a:solidFill>
-                <a:latin typeface="open sans" charset="0"/>
+                <a:latin typeface="Open Sans" charset="0"/>
               </a:rPr>
               <a:t>Body text</a:t>
             </a:r>
@@ -661,7 +661,7 @@
           <a:p>
             <a:fld id="{05CC55C5-3AE8-4299-988D-DFB8217A9B4E}" type="datetimeFigureOut">
               <a:rPr lang="en-GB" smtClean="0"/>
-              <a:t>18/04/2023</a:t>
+              <a:t>03/09/2026</a:t>
             </a:fld>
             <a:endParaRPr lang="en-GB"/>
           </a:p>
@@ -1343,7 +1343,7 @@
             <a:lvl1pPr marL="0" indent="0">
               <a:buNone/>
               <a:defRPr sz="1800" b="0" i="0" baseline="0">
-                <a:latin typeface="open sans" charset="0"/>
+                <a:latin typeface="Open Sans" charset="0"/>
               </a:defRPr>
             </a:lvl1pPr>
           </a:lstStyle>
@@ -1354,7 +1354,7 @@
                 <a:solidFill>
                   <a:schemeClr val="tx1"/>
                 </a:solidFill>
-                <a:latin typeface="open sans" charset="0"/>
+                <a:latin typeface="Open Sans" charset="0"/>
               </a:rPr>
               <a:t>Body Header</a:t>
             </a:r>
@@ -1365,7 +1365,7 @@
                 <a:solidFill>
                   <a:schemeClr val="tx1"/>
                 </a:solidFill>
-                <a:latin typeface="open sans" charset="0"/>
+                <a:latin typeface="Open Sans" charset="0"/>
               </a:rPr>
               <a:t>Body text</a:t>
             </a:r>
@@ -1639,7 +1639,7 @@
                 <a:solidFill>
                   <a:schemeClr val="tx1"/>
                 </a:solidFill>
-                <a:latin typeface="open sans" charset="0"/>
+                <a:latin typeface="Open Sans" charset="0"/>
               </a:rPr>
               <a:t>Body Header</a:t>
             </a:r>
@@ -1650,7 +1650,7 @@
                 <a:solidFill>
                   <a:schemeClr val="tx1"/>
                 </a:solidFill>
-                <a:latin typeface="open sans" charset="0"/>
+                <a:latin typeface="Open Sans" charset="0"/>
               </a:rPr>
               <a:t>Body text</a:t>
             </a:r>
@@ -1842,7 +1842,7 @@
           <a:solidFill>
             <a:schemeClr val="bg2"/>
           </a:solidFill>
-          <a:latin typeface="merriweather" charset="0"/>
+          <a:latin typeface="Merriweather" charset="0"/>
           <a:ea typeface="+mj-ea"/>
           <a:cs typeface="+mj-cs"/>
         </a:defRPr>
@@ -3210,7 +3210,7 @@
                 <a:solidFill>
                   <a:schemeClr val="tx1"/>
                 </a:solidFill>
-                <a:latin typeface="open sans" charset="0"/>
+                <a:latin typeface="Open Sans" charset="0"/>
                 <a:ea typeface="+mn-ea"/>
                 <a:cs typeface="+mn-cs"/>
               </a:defRPr>
@@ -5292,7 +5292,7 @@
         <p:spPr>
           <a:xfrm>
             <a:off x="233428" y="1487811"/>
-            <a:ext cx="2531032" cy="1754326"/>
+            <a:ext cx="2531032" cy="2031325"/>
           </a:xfrm>
           <a:prstGeom prst="rect">
             <a:avLst/>
@@ -5345,6 +5345,13 @@
             <a:r>
               <a:rPr lang="en-GB" dirty="0"/>
               <a:t>from an Exponential Distribution with rate parameter = 1/5</a:t>
+            </a:r>
+            <a:br>
+              <a:rPr lang="en-GB" dirty="0"/>
+            </a:br>
+            <a:r>
+              <a:rPr lang="en-GB" dirty="0"/>
+              <a:t>f(x) = 1/5*Exp(-1/5)x</a:t>
             </a:r>
             <a:endParaRPr lang="en-US" dirty="0"/>
           </a:p>
@@ -5419,12 +5426,8 @@
               <a:t> </a:t>
             </a:r>
             <a:r>
-              <a:rPr lang="en-GB"/>
-              <a:t>= -log(</a:t>
-            </a:r>
-            <a:r>
               <a:rPr lang="en-GB" dirty="0"/>
-              <a:t>1-y)</a:t>
+              <a:t>= -5*log(1-y)</a:t>
             </a:r>
           </a:p>
           <a:p>
@@ -5441,7 +5444,15 @@
             </a:r>
             <a:r>
               <a:rPr lang="en-GB" dirty="0"/>
-              <a:t> = -log(1-R</a:t>
+              <a:t> </a:t>
+            </a:r>
+            <a:r>
+              <a:rPr lang="en-GB"/>
+              <a:t>= -5*log</a:t>
+            </a:r>
+            <a:r>
+              <a:rPr lang="en-GB" dirty="0"/>
+              <a:t>(1-R</a:t>
             </a:r>
             <a:r>
               <a:rPr lang="en-GB" i="1" baseline="-25000" dirty="0"/>
@@ -6524,7 +6535,7 @@
                     <m:sSub>
                       <m:sSubPr>
                         <m:ctrlPr>
-                          <a:rPr i="1">
+                          <a:rPr>
                             <a:latin typeface="Cambria Math" panose="02040503050406030204" pitchFamily="18" charset="0"/>
                           </a:rPr>
                         </m:ctrlPr>
@@ -6997,7 +7008,7 @@
                     <m:sSub>
                       <m:sSubPr>
                         <m:ctrlPr>
-                          <a:rPr lang="ar-AE" sz="1600" i="1">
+                          <a:rPr lang="ar-AE" sz="1600">
                             <a:latin typeface="Cambria Math" panose="02040503050406030204" pitchFamily="18" charset="0"/>
                           </a:rPr>
                         </m:ctrlPr>
@@ -7245,7 +7256,7 @@
                     <m:sSub>
                       <m:sSubPr>
                         <m:ctrlPr>
-                          <a:rPr i="1">
+                          <a:rPr>
                             <a:latin typeface="Cambria Math" panose="02040503050406030204" pitchFamily="18" charset="0"/>
                           </a:rPr>
                         </m:ctrlPr>
@@ -7562,7 +7573,7 @@
                     <m:sSub>
                       <m:sSubPr>
                         <m:ctrlPr>
-                          <a:rPr lang="ar-AE" i="1">
+                          <a:rPr lang="ar-AE">
                             <a:latin typeface="Cambria Math" panose="02040503050406030204" pitchFamily="18" charset="0"/>
                           </a:rPr>
                         </m:ctrlPr>

</xml_diff>